<commit_message>
docs(scintillation): preserve review packet and campaign plans
</commit_message>
<xml_diff>
--- a/outputs/scintillation-acf-review/scintillation-acf-review.pptx
+++ b/outputs/scintillation-acf-review/scintillation-acf-review.pptx
@@ -2,16 +2,16 @@
 <file path=ppt/presentation.xml><?xml version="1.0" encoding="utf-8"?>
 <p:presentation xmlns:p="http://schemas.openxmlformats.org/presentationml/2006/main">
   <p:sldMasterIdLst>
-    <p:sldMasterId xmlns:r="http://schemas.openxmlformats.org/officeDocument/2006/relationships" id="2147483648" r:id="R3d0da9eff0dd4d6c"/>
+    <p:sldMasterId xmlns:r="http://schemas.openxmlformats.org/officeDocument/2006/relationships" id="2147483648" r:id="R6fde710d12ce4181"/>
   </p:sldMasterIdLst>
   <p:notesMasterIdLst>
-    <p:notesMasterId xmlns:r="http://schemas.openxmlformats.org/officeDocument/2006/relationships" r:id="R49d18c6f79c241a4"/>
+    <p:notesMasterId xmlns:r="http://schemas.openxmlformats.org/officeDocument/2006/relationships" r:id="R7392b80944814093"/>
   </p:notesMasterIdLst>
   <p:sldIdLst>
-    <p:sldId xmlns:r="http://schemas.openxmlformats.org/officeDocument/2006/relationships" id="256" r:id="R09466551f69e4cde"/>
-    <p:sldId xmlns:r="http://schemas.openxmlformats.org/officeDocument/2006/relationships" id="257" r:id="Ra769b8cd54854334"/>
-    <p:sldId xmlns:r="http://schemas.openxmlformats.org/officeDocument/2006/relationships" id="258" r:id="R90a0ce12cc314fbb"/>
-    <p:sldId xmlns:r="http://schemas.openxmlformats.org/officeDocument/2006/relationships" id="259" r:id="Rd9579e7202114a4d"/>
+    <p:sldId xmlns:r="http://schemas.openxmlformats.org/officeDocument/2006/relationships" id="256" r:id="R9058de772d394a63"/>
+    <p:sldId xmlns:r="http://schemas.openxmlformats.org/officeDocument/2006/relationships" id="257" r:id="R9a4c262f9222489e"/>
+    <p:sldId xmlns:r="http://schemas.openxmlformats.org/officeDocument/2006/relationships" id="258" r:id="R4aa9e29badd9432f"/>
+    <p:sldId xmlns:r="http://schemas.openxmlformats.org/officeDocument/2006/relationships" id="259" r:id="Rd2e7553966254d63"/>
   </p:sldIdLst>
   <p:sldSz cx="15240000" cy="8572500"/>
   <p:notesSz cx="6858000" cy="9144000"/>
@@ -802,7 +802,7 @@
   </p:cSld>
   <p:clrMap bg1="lt1" tx1="dk1" bg2="lt2" tx2="dk2" accent1="accent1" accent2="accent2" accent3="accent3" accent4="accent4" accent5="accent5" accent6="accent6" hlink="hlink" folHlink="folHlink"/>
   <p:sldLayoutIdLst>
-    <p:sldLayoutId xmlns:r="http://schemas.openxmlformats.org/officeDocument/2006/relationships" id="2147483649" r:id="R5f3f29c9caca4cb5"/>
+    <p:sldLayoutId xmlns:r="http://schemas.openxmlformats.org/officeDocument/2006/relationships" id="2147483649" r:id="R02b08cd974634abd"/>
   </p:sldLayoutIdLst>
   <p:txStyles>
     <p:titleStyle>
@@ -1335,7 +1335,7 @@
     <p:bg>
       <p:bgPr>
         <a:solidFill xmlns:a="http://schemas.openxmlformats.org/drawingml/2006/main">
-          <a:srgbClr val="F7F5EF"/>
+          <a:srgbClr val="1B1E28"/>
         </a:solidFill>
       </p:bgPr>
     </p:bg>
@@ -1350,10 +1350,10 @@
       </p:grpSpPr>
       <p:sp>
         <p:nvSpPr>
-          <p:cNvPr id="1" name="kicker">
+          <p:cNvPr id="1" name="title">
             <a:extLst xmlns:a="http://schemas.openxmlformats.org/drawingml/2006/main">
               <a:ext uri="{FF2B5EF4-FFF2-40B4-BE49-F238E27FC236}">
-                <a16:creationId xmlns:a16="http://schemas.microsoft.com/office/drawing/2014/main" id="{6F5410F2-4FC6-4657-8893-6F35BBE274C3}"/>
+                <a16:creationId xmlns:a16="http://schemas.microsoft.com/office/drawing/2014/main" id="{226424E2-5095-4FAA-B8A3-C0791329A25F}"/>
               </a:ext>
             </a:extLst>
           </p:cNvPr>
@@ -1364,8 +1364,8 @@
         </p:nvSpPr>
         <p:spPr>
           <a:xfrm xmlns:a="http://schemas.openxmlformats.org/drawingml/2006/main">
-            <a:off x="1047750" y="1028700"/>
-            <a:ext cx="9525000" cy="323850"/>
+            <a:off x="1333500" y="2667000"/>
+            <a:ext cx="12573000" cy="857250"/>
           </a:xfrm>
           <a:prstGeom xmlns:a="http://schemas.openxmlformats.org/drawingml/2006/main" prst="rect">
             <a:avLst/>
@@ -1380,30 +1380,30 @@
           <a:bodyPr xmlns:a="http://schemas.openxmlformats.org/drawingml/2006/main"/>
           <a:lstStyle xmlns:a="http://schemas.openxmlformats.org/drawingml/2006/main"/>
           <a:p xmlns:a="http://schemas.openxmlformats.org/drawingml/2006/main">
-            <a:pPr>
-              <a:defRPr sz="1500" b="1">
+            <a:pPr algn="ctr">
+              <a:defRPr sz="3900" b="1">
                 <a:solidFill>
-                  <a:srgbClr val="8A1C7C"/>
+                  <a:srgbClr val="FFFFFF"/>
                 </a:solidFill>
               </a:defRPr>
             </a:pPr>
             <a:r>
-              <a:rPr sz="1500" b="1">
+              <a:rPr sz="3900" b="1">
                 <a:solidFill>
-                  <a:srgbClr val="8A1C7C"/>
+                  <a:srgbClr val="FFFFFF"/>
                 </a:solidFill>
               </a:rPr>
-              <a:t>FABER2026 · SCINTILLATION REVALIDATION</a:t>
+              <a:t>Representative ACF outputs</a:t>
             </a:r>
           </a:p>
         </p:txBody>
       </p:sp>
       <p:sp>
         <p:nvSpPr>
-          <p:cNvPr id="2" name="title">
+          <p:cNvPr id="2" name="subtitle">
             <a:extLst xmlns:a="http://schemas.openxmlformats.org/drawingml/2006/main">
               <a:ext uri="{FF2B5EF4-FFF2-40B4-BE49-F238E27FC236}">
-                <a16:creationId xmlns:a16="http://schemas.microsoft.com/office/drawing/2014/main" id="{2E60160A-0B34-4174-BA56-F1759DB61E97}"/>
+                <a16:creationId xmlns:a16="http://schemas.microsoft.com/office/drawing/2014/main" id="{48101AF3-B96F-4CC8-966F-F09B1AD3C5B0}"/>
               </a:ext>
             </a:extLst>
           </p:cNvPr>
@@ -1414,8 +1414,8 @@
         </p:nvSpPr>
         <p:spPr>
           <a:xfrm xmlns:a="http://schemas.openxmlformats.org/drawingml/2006/main">
-            <a:off x="1047750" y="2343150"/>
-            <a:ext cx="12192000" cy="952500"/>
+            <a:off x="1714500" y="3810000"/>
+            <a:ext cx="11811000" cy="685800"/>
           </a:xfrm>
           <a:prstGeom xmlns:a="http://schemas.openxmlformats.org/drawingml/2006/main" prst="rect">
             <a:avLst/>
@@ -1430,30 +1430,30 @@
           <a:bodyPr xmlns:a="http://schemas.openxmlformats.org/drawingml/2006/main"/>
           <a:lstStyle xmlns:a="http://schemas.openxmlformats.org/drawingml/2006/main"/>
           <a:p xmlns:a="http://schemas.openxmlformats.org/drawingml/2006/main">
-            <a:pPr>
-              <a:defRPr sz="4350" b="1">
+            <a:pPr algn="ctr">
+              <a:defRPr sz="1800">
                 <a:solidFill>
-                  <a:srgbClr val="151515"/>
+                  <a:srgbClr val="5C6078"/>
                 </a:solidFill>
               </a:defRPr>
             </a:pPr>
             <a:r>
-              <a:rPr sz="4350" b="1">
+              <a:rPr sz="1800">
                 <a:solidFill>
-                  <a:srgbClr val="151515"/>
+                  <a:srgbClr val="5C6078"/>
                 </a:solidFill>
               </a:rPr>
-              <a:t>Representative ACF outputs</a:t>
+              <a:t>Freya and Casey DSA diagnostics, plus the Freya CHIME instrumental-control overview</a:t>
             </a:r>
           </a:p>
         </p:txBody>
       </p:sp>
       <p:sp>
         <p:nvSpPr>
-          <p:cNvPr id="3" name="subtitle">
+          <p:cNvPr id="3" name="status">
             <a:extLst xmlns:a="http://schemas.openxmlformats.org/drawingml/2006/main">
               <a:ext uri="{FF2B5EF4-FFF2-40B4-BE49-F238E27FC236}">
-                <a16:creationId xmlns:a16="http://schemas.microsoft.com/office/drawing/2014/main" id="{4AB8403D-AF45-44A9-A387-ADB7BA8D57C3}"/>
+                <a16:creationId xmlns:a16="http://schemas.microsoft.com/office/drawing/2014/main" id="{77E72EC7-1E53-46F0-8A01-B161F62315DD}"/>
               </a:ext>
             </a:extLst>
           </p:cNvPr>
@@ -1464,8 +1464,8 @@
         </p:nvSpPr>
         <p:spPr>
           <a:xfrm xmlns:a="http://schemas.openxmlformats.org/drawingml/2006/main">
-            <a:off x="1047750" y="3581400"/>
-            <a:ext cx="12001500" cy="1047750"/>
+            <a:off x="2857500" y="5334000"/>
+            <a:ext cx="9525000" cy="381000"/>
           </a:xfrm>
           <a:prstGeom xmlns:a="http://schemas.openxmlformats.org/drawingml/2006/main" prst="rect">
             <a:avLst/>
@@ -1480,70 +1480,20 @@
           <a:bodyPr xmlns:a="http://schemas.openxmlformats.org/drawingml/2006/main"/>
           <a:lstStyle xmlns:a="http://schemas.openxmlformats.org/drawingml/2006/main"/>
           <a:p xmlns:a="http://schemas.openxmlformats.org/drawingml/2006/main">
-            <a:pPr>
-              <a:defRPr sz="2250">
+            <a:pPr algn="ctr">
+              <a:defRPr sz="1350">
                 <a:solidFill>
-                  <a:srgbClr val="3F3F46"/>
+                  <a:srgbClr val="5C6078"/>
                 </a:solidFill>
               </a:defRPr>
             </a:pPr>
             <a:r>
-              <a:rPr sz="2250">
+              <a:rPr sz="1350">
                 <a:solidFill>
-                  <a:srgbClr val="3F3F46"/>
+                  <a:srgbClr val="5C6078"/>
                 </a:solidFill>
               </a:rPr>
-              <a:t>Freya and Casey DSA diagnostics, plus the Freya CHIME instrumental-control overview</a:t>
-            </a:r>
-          </a:p>
-        </p:txBody>
-      </p:sp>
-      <p:sp>
-        <p:nvSpPr>
-          <p:cNvPr id="4" name="status">
-            <a:extLst xmlns:a="http://schemas.openxmlformats.org/drawingml/2006/main">
-              <a:ext uri="{FF2B5EF4-FFF2-40B4-BE49-F238E27FC236}">
-                <a16:creationId xmlns:a16="http://schemas.microsoft.com/office/drawing/2014/main" id="{8BDEBFC3-7016-47AB-B788-8D3A5DE8950D}"/>
-              </a:ext>
-            </a:extLst>
-          </p:cNvPr>
-          <p:cNvSpPr>
-            <a:spLocks xmlns:a="http://schemas.openxmlformats.org/drawingml/2006/main" noGrp="1"/>
-          </p:cNvSpPr>
-          <p:nvPr/>
-        </p:nvSpPr>
-        <p:spPr>
-          <a:xfrm xmlns:a="http://schemas.openxmlformats.org/drawingml/2006/main">
-            <a:off x="1047750" y="6667500"/>
-            <a:ext cx="12192000" cy="438150"/>
-          </a:xfrm>
-          <a:prstGeom xmlns:a="http://schemas.openxmlformats.org/drawingml/2006/main" prst="rect">
-            <a:avLst/>
-          </a:prstGeom>
-          <a:noFill xmlns:a="http://schemas.openxmlformats.org/drawingml/2006/main"/>
-          <a:ln xmlns:a="http://schemas.openxmlformats.org/drawingml/2006/main" w="0">
-            <a:noFill/>
-            <a:prstDash val="solid"/>
-          </a:ln>
-        </p:spPr>
-        <p:txBody>
-          <a:bodyPr xmlns:a="http://schemas.openxmlformats.org/drawingml/2006/main"/>
-          <a:lstStyle xmlns:a="http://schemas.openxmlformats.org/drawingml/2006/main"/>
-          <a:p xmlns:a="http://schemas.openxmlformats.org/drawingml/2006/main">
-            <a:pPr>
-              <a:defRPr sz="1800" b="1">
-                <a:solidFill>
-                  <a:srgbClr val="8A1C7C"/>
-                </a:solidFill>
-              </a:defRPr>
-            </a:pPr>
-            <a:r>
-              <a:rPr sz="1800" b="1">
-                <a:solidFill>
-                  <a:srgbClr val="8A1C7C"/>
-                </a:solidFill>
-              </a:rPr>
-              <a:t>Current scientific status: DIAGNOSTIC ONLY · Phase 0 validation pending</a:t>
+              <a:t>Faber2026 · scintillation revalidation · DIAGNOSTIC ONLY</a:t>
             </a:r>
           </a:p>
         </p:txBody>
@@ -1551,7 +1501,7 @@
     </p:spTree>
     <p:extLst>
       <p:ext uri="{BB962C8B-B14F-4D97-AF65-F5344CB8AC3E}">
-        <p14:creationId xmlns:p14="http://schemas.microsoft.com/office/powerpoint/2010/main" val="1730670067"/>
+        <p14:creationId xmlns:p14="http://schemas.microsoft.com/office/powerpoint/2010/main" val="2130257719"/>
       </p:ext>
     </p:extLst>
   </p:cSld>
@@ -1564,7 +1514,7 @@
     <p:bg>
       <p:bgPr>
         <a:solidFill xmlns:a="http://schemas.openxmlformats.org/drawingml/2006/main">
-          <a:srgbClr val="FFFFFF"/>
+          <a:srgbClr val="1B1E28"/>
         </a:solidFill>
       </p:bgPr>
     </p:bg>
@@ -1582,7 +1532,7 @@
           <p:cNvPr id="1" name="title-0">
             <a:extLst xmlns:a="http://schemas.openxmlformats.org/drawingml/2006/main">
               <a:ext uri="{FF2B5EF4-FFF2-40B4-BE49-F238E27FC236}">
-                <a16:creationId xmlns:a16="http://schemas.microsoft.com/office/drawing/2014/main" id="{12C70956-D586-45EC-8DB8-F71509E44350}"/>
+                <a16:creationId xmlns:a16="http://schemas.microsoft.com/office/drawing/2014/main" id="{8AD88496-B4D9-4045-8DBE-CF746B4AB111}"/>
               </a:ext>
             </a:extLst>
           </p:cNvPr>
@@ -1593,8 +1543,8 @@
         </p:nvSpPr>
         <p:spPr>
           <a:xfrm xmlns:a="http://schemas.openxmlformats.org/drawingml/2006/main">
-            <a:off x="685800" y="342900"/>
-            <a:ext cx="11239500" cy="495300"/>
+            <a:off x="762000" y="419100"/>
+            <a:ext cx="13716000" cy="552450"/>
           </a:xfrm>
           <a:prstGeom xmlns:a="http://schemas.openxmlformats.org/drawingml/2006/main" prst="rect">
             <a:avLst/>
@@ -1609,17 +1559,17 @@
           <a:bodyPr xmlns:a="http://schemas.openxmlformats.org/drawingml/2006/main"/>
           <a:lstStyle xmlns:a="http://schemas.openxmlformats.org/drawingml/2006/main"/>
           <a:p xmlns:a="http://schemas.openxmlformats.org/drawingml/2006/main">
-            <a:pPr>
-              <a:defRPr sz="2850" b="1">
+            <a:pPr algn="ctr">
+              <a:defRPr sz="2700" b="1">
                 <a:solidFill>
-                  <a:srgbClr val="171717"/>
+                  <a:srgbClr val="FFFFFF"/>
                 </a:solidFill>
               </a:defRPr>
             </a:pPr>
             <a:r>
-              <a:rPr sz="2850" b="1">
+              <a:rPr sz="2700" b="1">
                 <a:solidFill>
-                  <a:srgbClr val="171717"/>
+                  <a:srgbClr val="FFFFFF"/>
                 </a:solidFill>
               </a:rPr>
               <a:t>Freya — DSA diagnostic ACF</a:t>
@@ -1627,12 +1577,34 @@
           </a:p>
         </p:txBody>
       </p:sp>
-      <p:sp>
-        <p:nvSpPr>
-          <p:cNvPr id="2" name="subtitle-0">
+      <p:pic>
+        <p:nvPicPr>
+          <p:cNvPr id="6" name=""/>
+          <p:cNvPicPr>
+            <a:picLocks xmlns:a="http://schemas.openxmlformats.org/drawingml/2006/main" noChangeAspect="1"/>
+          </p:cNvPicPr>
+          <p:nvPr/>
+        </p:nvPicPr>
+        <p:blipFill>
+          <a:blip xmlns:r="http://schemas.openxmlformats.org/officeDocument/2006/relationships" xmlns:a="http://schemas.openxmlformats.org/drawingml/2006/main" r:embed="R71e9f472f9ff4575"/>
+          <a:stretch xmlns:a="http://schemas.openxmlformats.org/drawingml/2006/main"/>
+        </p:blipFill>
+        <p:spPr>
+          <a:xfrm xmlns:a="http://schemas.openxmlformats.org/drawingml/2006/main">
+            <a:off x="2321279" y="1200150"/>
+            <a:ext cx="10597442" cy="6362700"/>
+          </a:xfrm>
+          <a:prstGeom xmlns:a="http://schemas.openxmlformats.org/drawingml/2006/main" prst="rect">
+            <a:avLst/>
+          </a:prstGeom>
+        </p:spPr>
+      </p:pic>
+      <p:sp>
+        <p:nvSpPr>
+          <p:cNvPr id="3" name="subtitle-0">
             <a:extLst xmlns:a="http://schemas.openxmlformats.org/drawingml/2006/main">
               <a:ext uri="{FF2B5EF4-FFF2-40B4-BE49-F238E27FC236}">
-                <a16:creationId xmlns:a16="http://schemas.microsoft.com/office/drawing/2014/main" id="{320A5260-D0D4-410D-A850-5F779BABEBB9}"/>
+                <a16:creationId xmlns:a16="http://schemas.microsoft.com/office/drawing/2014/main" id="{E648C6AE-F879-4725-83E1-9225E2093191}"/>
               </a:ext>
             </a:extLst>
           </p:cNvPr>
@@ -1643,8 +1615,8 @@
         </p:nvSpPr>
         <p:spPr>
           <a:xfrm xmlns:a="http://schemas.openxmlformats.org/drawingml/2006/main">
-            <a:off x="685800" y="838200"/>
-            <a:ext cx="13144500" cy="381000"/>
+            <a:off x="1714500" y="7715250"/>
+            <a:ext cx="11811000" cy="323850"/>
           </a:xfrm>
           <a:prstGeom xmlns:a="http://schemas.openxmlformats.org/drawingml/2006/main" prst="rect">
             <a:avLst/>
@@ -1659,17 +1631,17 @@
           <a:bodyPr xmlns:a="http://schemas.openxmlformats.org/drawingml/2006/main"/>
           <a:lstStyle xmlns:a="http://schemas.openxmlformats.org/drawingml/2006/main"/>
           <a:p xmlns:a="http://schemas.openxmlformats.org/drawingml/2006/main">
-            <a:pPr>
-              <a:defRPr sz="1500">
+            <a:pPr algn="ctr">
+              <a:defRPr sz="1200">
                 <a:solidFill>
-                  <a:srgbClr val="52525B"/>
+                  <a:srgbClr val="5C6078"/>
                 </a:solidFill>
               </a:defRPr>
             </a:pPr>
             <a:r>
-              <a:rPr sz="1500">
+              <a:rPr sz="1200">
                 <a:solidFill>
-                  <a:srgbClr val="52525B"/>
+                  <a:srgbClr val="5C6078"/>
                 </a:solidFill>
               </a:rPr>
               <a:t>Two sub-bands partitioned by equal integrated on-pulse signal (approximately equal S/N)</a:t>
@@ -1677,34 +1649,12 @@
           </a:p>
         </p:txBody>
       </p:sp>
-      <p:pic>
-        <p:nvPicPr>
-          <p:cNvPr id="7" name=""/>
-          <p:cNvPicPr>
-            <a:picLocks xmlns:a="http://schemas.openxmlformats.org/drawingml/2006/main" noChangeAspect="1"/>
-          </p:cNvPicPr>
-          <p:nvPr/>
-        </p:nvPicPr>
-        <p:blipFill>
-          <a:blip xmlns:r="http://schemas.openxmlformats.org/officeDocument/2006/relationships" xmlns:a="http://schemas.openxmlformats.org/drawingml/2006/main" r:embed="Ra47e325d21774147"/>
-          <a:stretch xmlns:a="http://schemas.openxmlformats.org/drawingml/2006/main"/>
-        </p:blipFill>
-        <p:spPr>
-          <a:xfrm xmlns:a="http://schemas.openxmlformats.org/drawingml/2006/main">
-            <a:off x="2035719" y="1295400"/>
-            <a:ext cx="11168562" cy="6705600"/>
-          </a:xfrm>
-          <a:prstGeom xmlns:a="http://schemas.openxmlformats.org/drawingml/2006/main" prst="rect">
-            <a:avLst/>
-          </a:prstGeom>
-        </p:spPr>
-      </p:pic>
       <p:sp>
         <p:nvSpPr>
           <p:cNvPr id="4" name="footer-0">
             <a:extLst xmlns:a="http://schemas.openxmlformats.org/drawingml/2006/main">
               <a:ext uri="{FF2B5EF4-FFF2-40B4-BE49-F238E27FC236}">
-                <a16:creationId xmlns:a16="http://schemas.microsoft.com/office/drawing/2014/main" id="{459A2A3E-DEB0-4167-8A5A-3F1878337BCF}"/>
+                <a16:creationId xmlns:a16="http://schemas.microsoft.com/office/drawing/2014/main" id="{C3E9FCD4-21D6-4AA5-8E5C-7710858A0778}"/>
               </a:ext>
             </a:extLst>
           </p:cNvPr>
@@ -1715,8 +1665,8 @@
         </p:nvSpPr>
         <p:spPr>
           <a:xfrm xmlns:a="http://schemas.openxmlformats.org/drawingml/2006/main">
-            <a:off x="13601700" y="8096250"/>
-            <a:ext cx="1047750" cy="228600"/>
+            <a:off x="13620750" y="8115300"/>
+            <a:ext cx="857250" cy="228600"/>
           </a:xfrm>
           <a:prstGeom xmlns:a="http://schemas.openxmlformats.org/drawingml/2006/main" prst="rect">
             <a:avLst/>
@@ -1732,16 +1682,16 @@
           <a:lstStyle xmlns:a="http://schemas.openxmlformats.org/drawingml/2006/main"/>
           <a:p xmlns:a="http://schemas.openxmlformats.org/drawingml/2006/main">
             <a:pPr algn="r">
-              <a:defRPr sz="1125">
+              <a:defRPr sz="975">
                 <a:solidFill>
-                  <a:srgbClr val="71717A"/>
+                  <a:srgbClr val="5C6078"/>
                 </a:solidFill>
               </a:defRPr>
             </a:pPr>
             <a:r>
-              <a:rPr sz="1125">
+              <a:rPr sz="975">
                 <a:solidFill>
-                  <a:srgbClr val="71717A"/>
+                  <a:srgbClr val="5C6078"/>
                 </a:solidFill>
               </a:rPr>
               <a:t>2 / 4</a:t>
@@ -1752,7 +1702,7 @@
     </p:spTree>
     <p:extLst>
       <p:ext uri="{BB962C8B-B14F-4D97-AF65-F5344CB8AC3E}">
-        <p14:creationId xmlns:p14="http://schemas.microsoft.com/office/powerpoint/2010/main" val="677897081"/>
+        <p14:creationId xmlns:p14="http://schemas.microsoft.com/office/powerpoint/2010/main" val="1838650034"/>
       </p:ext>
     </p:extLst>
   </p:cSld>
@@ -1765,7 +1715,7 @@
     <p:bg>
       <p:bgPr>
         <a:solidFill xmlns:a="http://schemas.openxmlformats.org/drawingml/2006/main">
-          <a:srgbClr val="FFFFFF"/>
+          <a:srgbClr val="1B1E28"/>
         </a:solidFill>
       </p:bgPr>
     </p:bg>
@@ -1783,7 +1733,7 @@
           <p:cNvPr id="1" name="title-1">
             <a:extLst xmlns:a="http://schemas.openxmlformats.org/drawingml/2006/main">
               <a:ext uri="{FF2B5EF4-FFF2-40B4-BE49-F238E27FC236}">
-                <a16:creationId xmlns:a16="http://schemas.microsoft.com/office/drawing/2014/main" id="{81249375-45CF-45B7-B3A1-8EB8D57F02CE}"/>
+                <a16:creationId xmlns:a16="http://schemas.microsoft.com/office/drawing/2014/main" id="{97DC9CEE-3BFB-4F74-BBCD-75EEB6FF0C44}"/>
               </a:ext>
             </a:extLst>
           </p:cNvPr>
@@ -1794,8 +1744,8 @@
         </p:nvSpPr>
         <p:spPr>
           <a:xfrm xmlns:a="http://schemas.openxmlformats.org/drawingml/2006/main">
-            <a:off x="685800" y="342900"/>
-            <a:ext cx="11239500" cy="495300"/>
+            <a:off x="762000" y="419100"/>
+            <a:ext cx="13716000" cy="552450"/>
           </a:xfrm>
           <a:prstGeom xmlns:a="http://schemas.openxmlformats.org/drawingml/2006/main" prst="rect">
             <a:avLst/>
@@ -1810,17 +1760,17 @@
           <a:bodyPr xmlns:a="http://schemas.openxmlformats.org/drawingml/2006/main"/>
           <a:lstStyle xmlns:a="http://schemas.openxmlformats.org/drawingml/2006/main"/>
           <a:p xmlns:a="http://schemas.openxmlformats.org/drawingml/2006/main">
-            <a:pPr>
-              <a:defRPr sz="2850" b="1">
+            <a:pPr algn="ctr">
+              <a:defRPr sz="2700" b="1">
                 <a:solidFill>
-                  <a:srgbClr val="171717"/>
+                  <a:srgbClr val="FFFFFF"/>
                 </a:solidFill>
               </a:defRPr>
             </a:pPr>
             <a:r>
-              <a:rPr sz="2850" b="1">
+              <a:rPr sz="2700" b="1">
                 <a:solidFill>
-                  <a:srgbClr val="171717"/>
+                  <a:srgbClr val="FFFFFF"/>
                 </a:solidFill>
               </a:rPr>
               <a:t>Casey — DSA diagnostic ACF</a:t>
@@ -1828,12 +1778,34 @@
           </a:p>
         </p:txBody>
       </p:sp>
-      <p:sp>
-        <p:nvSpPr>
-          <p:cNvPr id="2" name="subtitle-1">
+      <p:pic>
+        <p:nvPicPr>
+          <p:cNvPr id="6" name=""/>
+          <p:cNvPicPr>
+            <a:picLocks xmlns:a="http://schemas.openxmlformats.org/drawingml/2006/main" noChangeAspect="1"/>
+          </p:cNvPicPr>
+          <p:nvPr/>
+        </p:nvPicPr>
+        <p:blipFill>
+          <a:blip xmlns:r="http://schemas.openxmlformats.org/officeDocument/2006/relationships" xmlns:a="http://schemas.openxmlformats.org/drawingml/2006/main" r:embed="Rf90d876e6b9e406c"/>
+          <a:stretch xmlns:a="http://schemas.openxmlformats.org/drawingml/2006/main"/>
+        </p:blipFill>
+        <p:spPr>
+          <a:xfrm xmlns:a="http://schemas.openxmlformats.org/drawingml/2006/main">
+            <a:off x="3938461" y="1200150"/>
+            <a:ext cx="7363078" cy="6362700"/>
+          </a:xfrm>
+          <a:prstGeom xmlns:a="http://schemas.openxmlformats.org/drawingml/2006/main" prst="rect">
+            <a:avLst/>
+          </a:prstGeom>
+        </p:spPr>
+      </p:pic>
+      <p:sp>
+        <p:nvSpPr>
+          <p:cNvPr id="3" name="subtitle-1">
             <a:extLst xmlns:a="http://schemas.openxmlformats.org/drawingml/2006/main">
               <a:ext uri="{FF2B5EF4-FFF2-40B4-BE49-F238E27FC236}">
-                <a16:creationId xmlns:a16="http://schemas.microsoft.com/office/drawing/2014/main" id="{F12404BF-54D1-4A27-81D5-67D3C02A7105}"/>
+                <a16:creationId xmlns:a16="http://schemas.microsoft.com/office/drawing/2014/main" id="{D58487E1-F376-49AB-9F71-3B164F4BA62C}"/>
               </a:ext>
             </a:extLst>
           </p:cNvPr>
@@ -1844,8 +1816,8 @@
         </p:nvSpPr>
         <p:spPr>
           <a:xfrm xmlns:a="http://schemas.openxmlformats.org/drawingml/2006/main">
-            <a:off x="685800" y="838200"/>
-            <a:ext cx="13144500" cy="381000"/>
+            <a:off x="1714500" y="7715250"/>
+            <a:ext cx="11811000" cy="323850"/>
           </a:xfrm>
           <a:prstGeom xmlns:a="http://schemas.openxmlformats.org/drawingml/2006/main" prst="rect">
             <a:avLst/>
@@ -1860,17 +1832,17 @@
           <a:bodyPr xmlns:a="http://schemas.openxmlformats.org/drawingml/2006/main"/>
           <a:lstStyle xmlns:a="http://schemas.openxmlformats.org/drawingml/2006/main"/>
           <a:p xmlns:a="http://schemas.openxmlformats.org/drawingml/2006/main">
-            <a:pPr>
-              <a:defRPr sz="1500">
+            <a:pPr algn="ctr">
+              <a:defRPr sz="1200">
                 <a:solidFill>
-                  <a:srgbClr val="52525B"/>
+                  <a:srgbClr val="5C6078"/>
                 </a:solidFill>
               </a:defRPr>
             </a:pPr>
             <a:r>
-              <a:rPr sz="1500">
+              <a:rPr sz="1200">
                 <a:solidFill>
-                  <a:srgbClr val="52525B"/>
+                  <a:srgbClr val="5C6078"/>
                 </a:solidFill>
               </a:rPr>
               <a:t>Four sub-bands partitioned by equal integrated on-pulse signal (approximately equal S/N)</a:t>
@@ -1878,34 +1850,12 @@
           </a:p>
         </p:txBody>
       </p:sp>
-      <p:pic>
-        <p:nvPicPr>
-          <p:cNvPr id="7" name=""/>
-          <p:cNvPicPr>
-            <a:picLocks xmlns:a="http://schemas.openxmlformats.org/drawingml/2006/main" noChangeAspect="1"/>
-          </p:cNvPicPr>
-          <p:nvPr/>
-        </p:nvPicPr>
-        <p:blipFill>
-          <a:blip xmlns:r="http://schemas.openxmlformats.org/officeDocument/2006/relationships" xmlns:a="http://schemas.openxmlformats.org/drawingml/2006/main" r:embed="R5ae715c6c7544ec4"/>
-          <a:stretch xmlns:a="http://schemas.openxmlformats.org/drawingml/2006/main"/>
-        </p:blipFill>
-        <p:spPr>
-          <a:xfrm xmlns:a="http://schemas.openxmlformats.org/drawingml/2006/main">
-            <a:off x="3740055" y="1295400"/>
-            <a:ext cx="7759891" cy="6705600"/>
-          </a:xfrm>
-          <a:prstGeom xmlns:a="http://schemas.openxmlformats.org/drawingml/2006/main" prst="rect">
-            <a:avLst/>
-          </a:prstGeom>
-        </p:spPr>
-      </p:pic>
       <p:sp>
         <p:nvSpPr>
           <p:cNvPr id="4" name="footer-1">
             <a:extLst xmlns:a="http://schemas.openxmlformats.org/drawingml/2006/main">
               <a:ext uri="{FF2B5EF4-FFF2-40B4-BE49-F238E27FC236}">
-                <a16:creationId xmlns:a16="http://schemas.microsoft.com/office/drawing/2014/main" id="{7D9E1FF3-C86C-4621-B720-1FCB963FC786}"/>
+                <a16:creationId xmlns:a16="http://schemas.microsoft.com/office/drawing/2014/main" id="{2DD34382-6CCA-44D8-8C59-2A51CE110E97}"/>
               </a:ext>
             </a:extLst>
           </p:cNvPr>
@@ -1916,8 +1866,8 @@
         </p:nvSpPr>
         <p:spPr>
           <a:xfrm xmlns:a="http://schemas.openxmlformats.org/drawingml/2006/main">
-            <a:off x="13601700" y="8096250"/>
-            <a:ext cx="1047750" cy="228600"/>
+            <a:off x="13620750" y="8115300"/>
+            <a:ext cx="857250" cy="228600"/>
           </a:xfrm>
           <a:prstGeom xmlns:a="http://schemas.openxmlformats.org/drawingml/2006/main" prst="rect">
             <a:avLst/>
@@ -1933,16 +1883,16 @@
           <a:lstStyle xmlns:a="http://schemas.openxmlformats.org/drawingml/2006/main"/>
           <a:p xmlns:a="http://schemas.openxmlformats.org/drawingml/2006/main">
             <a:pPr algn="r">
-              <a:defRPr sz="1125">
+              <a:defRPr sz="975">
                 <a:solidFill>
-                  <a:srgbClr val="71717A"/>
+                  <a:srgbClr val="5C6078"/>
                 </a:solidFill>
               </a:defRPr>
             </a:pPr>
             <a:r>
-              <a:rPr sz="1125">
+              <a:rPr sz="975">
                 <a:solidFill>
-                  <a:srgbClr val="71717A"/>
+                  <a:srgbClr val="5C6078"/>
                 </a:solidFill>
               </a:rPr>
               <a:t>3 / 4</a:t>
@@ -1953,7 +1903,7 @@
     </p:spTree>
     <p:extLst>
       <p:ext uri="{BB962C8B-B14F-4D97-AF65-F5344CB8AC3E}">
-        <p14:creationId xmlns:p14="http://schemas.microsoft.com/office/powerpoint/2010/main" val="1120741658"/>
+        <p14:creationId xmlns:p14="http://schemas.microsoft.com/office/powerpoint/2010/main" val="1746159606"/>
       </p:ext>
     </p:extLst>
   </p:cSld>
@@ -1966,7 +1916,7 @@
     <p:bg>
       <p:bgPr>
         <a:solidFill xmlns:a="http://schemas.openxmlformats.org/drawingml/2006/main">
-          <a:srgbClr val="FFFFFF"/>
+          <a:srgbClr val="1B1E28"/>
         </a:solidFill>
       </p:bgPr>
     </p:bg>
@@ -1984,7 +1934,7 @@
           <p:cNvPr id="1" name="title-2">
             <a:extLst xmlns:a="http://schemas.openxmlformats.org/drawingml/2006/main">
               <a:ext uri="{FF2B5EF4-FFF2-40B4-BE49-F238E27FC236}">
-                <a16:creationId xmlns:a16="http://schemas.microsoft.com/office/drawing/2014/main" id="{669B06B8-93D6-442C-85F0-7FB2AAFAD0FF}"/>
+                <a16:creationId xmlns:a16="http://schemas.microsoft.com/office/drawing/2014/main" id="{E1AC1832-4D32-4D64-A5F4-A34799A00A1A}"/>
               </a:ext>
             </a:extLst>
           </p:cNvPr>
@@ -1995,8 +1945,8 @@
         </p:nvSpPr>
         <p:spPr>
           <a:xfrm xmlns:a="http://schemas.openxmlformats.org/drawingml/2006/main">
-            <a:off x="685800" y="342900"/>
-            <a:ext cx="11239500" cy="495300"/>
+            <a:off x="762000" y="419100"/>
+            <a:ext cx="13716000" cy="552450"/>
           </a:xfrm>
           <a:prstGeom xmlns:a="http://schemas.openxmlformats.org/drawingml/2006/main" prst="rect">
             <a:avLst/>
@@ -2011,17 +1961,17 @@
           <a:bodyPr xmlns:a="http://schemas.openxmlformats.org/drawingml/2006/main"/>
           <a:lstStyle xmlns:a="http://schemas.openxmlformats.org/drawingml/2006/main"/>
           <a:p xmlns:a="http://schemas.openxmlformats.org/drawingml/2006/main">
-            <a:pPr>
-              <a:defRPr sz="2850" b="1">
+            <a:pPr algn="ctr">
+              <a:defRPr sz="2700" b="1">
                 <a:solidFill>
-                  <a:srgbClr val="171717"/>
+                  <a:srgbClr val="FFFFFF"/>
                 </a:solidFill>
               </a:defRPr>
             </a:pPr>
             <a:r>
-              <a:rPr sz="2850" b="1">
+              <a:rPr sz="2700" b="1">
                 <a:solidFill>
-                  <a:srgbClr val="171717"/>
+                  <a:srgbClr val="FFFFFF"/>
                 </a:solidFill>
               </a:rPr>
               <a:t>Freya — CHIME instrumental-origin control</a:t>
@@ -2029,12 +1979,34 @@
           </a:p>
         </p:txBody>
       </p:sp>
-      <p:sp>
-        <p:nvSpPr>
-          <p:cNvPr id="2" name="subtitle-2">
+      <p:pic>
+        <p:nvPicPr>
+          <p:cNvPr id="6" name=""/>
+          <p:cNvPicPr>
+            <a:picLocks xmlns:a="http://schemas.openxmlformats.org/drawingml/2006/main" noChangeAspect="1"/>
+          </p:cNvPicPr>
+          <p:nvPr/>
+        </p:nvPicPr>
+        <p:blipFill>
+          <a:blip xmlns:r="http://schemas.openxmlformats.org/officeDocument/2006/relationships" xmlns:a="http://schemas.openxmlformats.org/drawingml/2006/main" r:embed="R22d00f3ac83b43a8"/>
+          <a:stretch xmlns:a="http://schemas.openxmlformats.org/drawingml/2006/main"/>
+        </p:blipFill>
+        <p:spPr>
+          <a:xfrm xmlns:a="http://schemas.openxmlformats.org/drawingml/2006/main">
+            <a:off x="3434013" y="1200150"/>
+            <a:ext cx="8371974" cy="6362700"/>
+          </a:xfrm>
+          <a:prstGeom xmlns:a="http://schemas.openxmlformats.org/drawingml/2006/main" prst="rect">
+            <a:avLst/>
+          </a:prstGeom>
+        </p:spPr>
+      </p:pic>
+      <p:sp>
+        <p:nvSpPr>
+          <p:cNvPr id="3" name="subtitle-2">
             <a:extLst xmlns:a="http://schemas.openxmlformats.org/drawingml/2006/main">
               <a:ext uri="{FF2B5EF4-FFF2-40B4-BE49-F238E27FC236}">
-                <a16:creationId xmlns:a16="http://schemas.microsoft.com/office/drawing/2014/main" id="{BA94D506-CE46-4335-A762-D5D727E19287}"/>
+                <a16:creationId xmlns:a16="http://schemas.microsoft.com/office/drawing/2014/main" id="{C153CD9B-9409-400B-BF45-1F271CAA25B4}"/>
               </a:ext>
             </a:extLst>
           </p:cNvPr>
@@ -2045,8 +2017,8 @@
         </p:nvSpPr>
         <p:spPr>
           <a:xfrm xmlns:a="http://schemas.openxmlformats.org/drawingml/2006/main">
-            <a:off x="685800" y="838200"/>
-            <a:ext cx="13144500" cy="381000"/>
+            <a:off x="1714500" y="7715250"/>
+            <a:ext cx="11811000" cy="323850"/>
           </a:xfrm>
           <a:prstGeom xmlns:a="http://schemas.openxmlformats.org/drawingml/2006/main" prst="rect">
             <a:avLst/>
@@ -2061,17 +2033,17 @@
           <a:bodyPr xmlns:a="http://schemas.openxmlformats.org/drawingml/2006/main"/>
           <a:lstStyle xmlns:a="http://schemas.openxmlformats.org/drawingml/2006/main"/>
           <a:p xmlns:a="http://schemas.openxmlformats.org/drawingml/2006/main">
-            <a:pPr>
-              <a:defRPr sz="1500">
+            <a:pPr algn="ctr">
+              <a:defRPr sz="1200">
                 <a:solidFill>
-                  <a:srgbClr val="52525B"/>
+                  <a:srgbClr val="5C6078"/>
                 </a:solidFill>
               </a:defRPr>
             </a:pPr>
             <a:r>
-              <a:rPr sz="1500">
+              <a:rPr sz="1200">
                 <a:solidFill>
-                  <a:srgbClr val="52525B"/>
+                  <a:srgbClr val="5C6078"/>
                 </a:solidFill>
               </a:rPr>
               <a:t>Original 2026-07-05 overview retained for direct comparison</a:t>
@@ -2079,34 +2051,12 @@
           </a:p>
         </p:txBody>
       </p:sp>
-      <p:pic>
-        <p:nvPicPr>
-          <p:cNvPr id="7" name=""/>
-          <p:cNvPicPr>
-            <a:picLocks xmlns:a="http://schemas.openxmlformats.org/drawingml/2006/main" noChangeAspect="1"/>
-          </p:cNvPicPr>
-          <p:nvPr/>
-        </p:nvPicPr>
-        <p:blipFill>
-          <a:blip xmlns:r="http://schemas.openxmlformats.org/officeDocument/2006/relationships" xmlns:a="http://schemas.openxmlformats.org/drawingml/2006/main" r:embed="R613af830b7ce4163"/>
-          <a:stretch xmlns:a="http://schemas.openxmlformats.org/drawingml/2006/main"/>
-        </p:blipFill>
-        <p:spPr>
-          <a:xfrm xmlns:a="http://schemas.openxmlformats.org/drawingml/2006/main">
-            <a:off x="3208421" y="1295400"/>
-            <a:ext cx="8823158" cy="6705600"/>
-          </a:xfrm>
-          <a:prstGeom xmlns:a="http://schemas.openxmlformats.org/drawingml/2006/main" prst="rect">
-            <a:avLst/>
-          </a:prstGeom>
-        </p:spPr>
-      </p:pic>
       <p:sp>
         <p:nvSpPr>
           <p:cNvPr id="4" name="footer-2">
             <a:extLst xmlns:a="http://schemas.openxmlformats.org/drawingml/2006/main">
               <a:ext uri="{FF2B5EF4-FFF2-40B4-BE49-F238E27FC236}">
-                <a16:creationId xmlns:a16="http://schemas.microsoft.com/office/drawing/2014/main" id="{6E7F4EF9-FAF4-41F2-812D-5EE78C8ACAB1}"/>
+                <a16:creationId xmlns:a16="http://schemas.microsoft.com/office/drawing/2014/main" id="{A61D0650-9819-482E-AC2C-B7CF98539EA5}"/>
               </a:ext>
             </a:extLst>
           </p:cNvPr>
@@ -2117,8 +2067,8 @@
         </p:nvSpPr>
         <p:spPr>
           <a:xfrm xmlns:a="http://schemas.openxmlformats.org/drawingml/2006/main">
-            <a:off x="13601700" y="8096250"/>
-            <a:ext cx="1047750" cy="228600"/>
+            <a:off x="13620750" y="8115300"/>
+            <a:ext cx="857250" cy="228600"/>
           </a:xfrm>
           <a:prstGeom xmlns:a="http://schemas.openxmlformats.org/drawingml/2006/main" prst="rect">
             <a:avLst/>
@@ -2134,16 +2084,16 @@
           <a:lstStyle xmlns:a="http://schemas.openxmlformats.org/drawingml/2006/main"/>
           <a:p xmlns:a="http://schemas.openxmlformats.org/drawingml/2006/main">
             <a:pPr algn="r">
-              <a:defRPr sz="1125">
+              <a:defRPr sz="975">
                 <a:solidFill>
-                  <a:srgbClr val="71717A"/>
+                  <a:srgbClr val="5C6078"/>
                 </a:solidFill>
               </a:defRPr>
             </a:pPr>
             <a:r>
-              <a:rPr sz="1125">
+              <a:rPr sz="975">
                 <a:solidFill>
-                  <a:srgbClr val="71717A"/>
+                  <a:srgbClr val="5C6078"/>
                 </a:solidFill>
               </a:rPr>
               <a:t>4 / 4</a:t>
@@ -2154,7 +2104,7 @@
     </p:spTree>
     <p:extLst>
       <p:ext uri="{BB962C8B-B14F-4D97-AF65-F5344CB8AC3E}">
-        <p14:creationId xmlns:p14="http://schemas.microsoft.com/office/powerpoint/2010/main" val="468544226"/>
+        <p14:creationId xmlns:p14="http://schemas.microsoft.com/office/powerpoint/2010/main" val="1667095756"/>
       </p:ext>
     </p:extLst>
   </p:cSld>

</xml_diff>